<commit_message>
updated with new annotationb file
</commit_message>
<xml_diff>
--- a/presentation/capstone_walkthrough.pptx
+++ b/presentation/capstone_walkthrough.pptx
@@ -3364,7 +3364,7 @@
           <a:p/>
           <a:p>
             <a:r>
-              <a:t>On the method side: mini matches my labels on about two-thirds of posts, and two humans only agree at kappa 0.57; the hybrid's 0.680 is optimistic; the 2,606 corpus reassignments aren't human-checked; and a multi-brand post gives its one sentiment to every brand it names.</a:t>
+              <a:t>On the method side: mini matches my labels on about two-thirds of posts, and two humans only agree at kappa 0.38; the hybrid's 0.680 is optimistic; the 2,606 corpus reassignments aren't human-checked; and a multi-brand post gives its one sentiment to every brand it names.</a:t>
             </a:r>
           </a:p>
         </p:txBody>
@@ -3751,12 +3751,12 @@
           </a:p>
           <a:p>
             <a:r>
-              <a:t>A: Headline metrics use one annotator. Two annotators agree at κ 0.57 on representative posts. Challenge agreement (0.76) is unusually high, so I’m confirming it was independent.</a:t>
-            </a:r>
-          </a:p>
-          <a:p>
-            <a:r>
-              <a:t>Per-label issue κ on the representative overlap is low for Devices (0.14) and Customer Service (0.18). On the challenge overlap 21 of 40 rows are identical on every field, and four notes match word for word.</a:t>
+              <a:t>A: Headline metrics use one annotator. Two annotators agree at κ 0.38 on typical posts, mostly on whether “Singtel is down” is a complaint or a fact. I’ve added that rule to the guide.</a:t>
+            </a:r>
+          </a:p>
+          <a:p>
+            <a:r>
+              <a:t>Per-label issue κ on the representative overlap is low for Devices (0.14) and Customer Service (0.18). On the challenge overlap 18 of 40 rows are identical on every field, and four notes match word for word. An earlier version of B's sheet was superseded: its labels contradicted B's own notes.</a:t>
             </a:r>
           </a:p>
         </p:txBody>
@@ -4025,7 +4025,13 @@
           <a:lstStyle/>
           <a:p>
             <a:r>
-              <a:t>These are preliminary numbers from the 100 overlap posts, computed per set as the project rules require. Representative sentiment kappa is 0.57, moderate; challenge is 0.76. The per-label issue kappas show that humans also disagree on Devices and Customer Service, which caps how well any model can score on them. The challenge set's near-perfect issue agreement is unusual for hard cases, so I'm confirming the second annotator worked independently before I report it.</a:t>
+              <a:t>Inter-annotator agreement on the 100 overlap posts, per set. Representative sentiment kappa is 0.38, fair at best; challenge is 0.63. Most disagreements are one pattern: posts I labelled not happy that the second annotator labelled neutral, like 'Ya Singtel is down', questions about compensation, or troubleshooting tips. My guide listed 'service failure' as not happy and 'factual statement' as neutral, but never said which wins when a post is both. So it's a guide gap, and it matters: GPT-4o-mini reads those posts the way I do, so part of its margin over VADER depends on that rule. I've now added it to the guide.</a:t>
+            </a:r>
+          </a:p>
+          <a:p/>
+          <a:p>
+            <a:r>
+              <a:t>Two cautions. An earlier version of the second annotator's sheet is superseded, because its labels contradicted their own notes and matched mine. And on the challenge rows 18 of 40 still match me on every field, so I don't rely on the 0.63 until I've confirmed they worked independently.</a:t>
             </a:r>
           </a:p>
         </p:txBody>
@@ -18805,7 +18811,7 @@
                 </a:solidFill>
                 <a:latin typeface="Calibri"/>
               </a:rPr>
-              <a:t>Mini matches humans on ~2/3 of posts; humans agree at κ 0.57</a:t>
+              <a:t>Mini matches humans on ~2/3 of posts; humans agree at κ 0.38</a:t>
             </a:r>
           </a:p>
           <a:p>
@@ -20900,7 +20906,7 @@
                 </a:solidFill>
                 <a:latin typeface="Calibri"/>
               </a:rPr>
-              <a:t>Headline metrics use one annotator. Two annotators agree at κ 0.57 on representative posts. Challenge agreement (0.76) is unusually high, so I’m confirming it was independent.</a:t>
+              <a:t>Headline metrics use one annotator. Two annotators agree at κ 0.38 on typical posts, mostly on whether “Singtel is down” is a complaint or a fact. I’ve added that rule to the guide.</a:t>
             </a:r>
           </a:p>
         </p:txBody>
@@ -21897,7 +21903,7 @@
                 </a:solidFill>
                 <a:latin typeface="Calibri"/>
               </a:rPr>
-              <a:t>Backup: inter-annotator agreement (preliminary)</a:t>
+              <a:t>Backup: two humans disagree on outage reports</a:t>
             </a:r>
           </a:p>
         </p:txBody>
@@ -22143,7 +22149,7 @@
                           </a:solidFill>
                           <a:latin typeface="Calibri"/>
                         </a:rPr>
-                        <a:t>74%</a:t>
+                        <a:t>60%</a:t>
                       </a:r>
                     </a:p>
                   </a:txBody>
@@ -22166,7 +22172,7 @@
                           </a:solidFill>
                           <a:latin typeface="Calibri"/>
                         </a:rPr>
-                        <a:t>0.57</a:t>
+                        <a:t>0.38</a:t>
                       </a:r>
                     </a:p>
                   </a:txBody>
@@ -22260,7 +22266,7 @@
                           </a:solidFill>
                           <a:latin typeface="Calibri"/>
                         </a:rPr>
-                        <a:t>85%</a:t>
+                        <a:t>75%</a:t>
                       </a:r>
                     </a:p>
                   </a:txBody>
@@ -22283,7 +22289,7 @@
                           </a:solidFill>
                           <a:latin typeface="Calibri"/>
                         </a:rPr>
-                        <a:t>0.76</a:t>
+                        <a:t>0.63</a:t>
                       </a:r>
                     </a:p>
                   </a:txBody>
@@ -22330,7 +22336,7 @@
         <p:spPr>
           <a:xfrm>
             <a:off x="548640" y="3703320"/>
-            <a:ext cx="5394960" cy="1737360"/>
+            <a:ext cx="5394960" cy="2011680"/>
           </a:xfrm>
           <a:prstGeom prst="roundRect">
             <a:avLst>
@@ -22401,7 +22407,7 @@
                 </a:solidFill>
                 <a:latin typeface="Calibri"/>
               </a:rPr>
-              <a:t>Low human ceiling</a:t>
+              <a:t>One rule explains most of it</a:t>
             </a:r>
           </a:p>
         </p:txBody>
@@ -22415,7 +22421,7 @@
         <p:spPr>
           <a:xfrm>
             <a:off x="777240" y="4270248"/>
-            <a:ext cx="4937760" cy="1005839"/>
+            <a:ext cx="4937760" cy="1280160"/>
           </a:xfrm>
           <a:prstGeom prst="rect">
             <a:avLst/>
@@ -22440,7 +22446,7 @@
                 </a:solidFill>
                 <a:latin typeface="Calibri"/>
               </a:rPr>
-              <a:t>Issue κ on the representative overlap: Devices 0.14, Customer Service 0.18. Humans disagree on these labels too.</a:t>
+              <a:t>12 of 23 representative disagreements (8 of 10 on challenge): I said not happy, B said neutral, on bare outage reports and questions.</a:t>
             </a:r>
           </a:p>
         </p:txBody>
@@ -22454,7 +22460,7 @@
         <p:spPr>
           <a:xfrm>
             <a:off x="6245352" y="3703320"/>
-            <a:ext cx="5394960" cy="1737360"/>
+            <a:ext cx="5394960" cy="2011680"/>
           </a:xfrm>
           <a:prstGeom prst="roundRect">
             <a:avLst>
@@ -22525,7 +22531,7 @@
                 </a:solidFill>
                 <a:latin typeface="Calibri"/>
               </a:rPr>
-              <a:t>Check before reporting</a:t>
+              <a:t>Fixed, then check</a:t>
             </a:r>
           </a:p>
         </p:txBody>
@@ -22539,7 +22545,7 @@
         <p:spPr>
           <a:xfrm>
             <a:off x="6473952" y="4270248"/>
-            <a:ext cx="4937760" cy="1005839"/>
+            <a:ext cx="4937760" cy="1280160"/>
           </a:xfrm>
           <a:prstGeom prst="rect">
             <a:avLst/>
@@ -22564,7 +22570,7 @@
                 </a:solidFill>
                 <a:latin typeface="Calibri"/>
               </a:rPr>
-              <a:t>Challenge agreement is higher than representative, unusual for hard cases. Confirm the second annotator labelled independently.</a:t>
+              <a:t>Guide now says a first-hand failure report is not happy. Next: relabel the overlap and confirm B's independence (18/40 identical).</a:t>
             </a:r>
           </a:p>
         </p:txBody>

</xml_diff>